<commit_message>
v0.28.1: updated library slides — per-variant storage figures
Both library skeletons re-edited in the reference corpus and re-extracted
into the skeleton store (template_slides.py --extract; the 12 unrelated
skeletons the extraction re-encoded byte-identically-in-content were
restored rather than committed as churn). Headlines now read
">200,000 images" on the ov20i/ov10i slide (library.pptx) and
">25,000 images" on the ov80i one (library_ov80i.pptx), replacing the
shared ">20,000". Verified: hole profiles intact (one library_screen slot
each), skeleton/spec suites green against the shipping store, both slides
filled and rendered for review.

Co-Authored-By: Claude Fable 5 <noreply@anthropic.com>
Claude-Session: https://claude.ai/code/session_01AtSm6SGhrwojo1499w18c1
</commit_message>
<xml_diff>
--- a/skills/overview-deck/assets/reference/library_ov80i.pptx
+++ b/skills/overview-deck/assets/reference/library_ov80i.pptx
@@ -750,7 +750,7 @@
       </p:grpSpPr>
       <p:sp>
         <p:nvSpPr>
-          <p:cNvPr id="256" name="Google Shape;256;g3f6ecb44592_2_205:notes"/>
+          <p:cNvPr id="256" name="Google Shape;256;g3f88a2c7065_4_205:notes"/>
           <p:cNvSpPr txBox="1"/>
           <p:nvPr>
             <p:ph idx="1" type="body"/>
@@ -764,6 +764,10 @@
           <a:prstGeom prst="rect">
             <a:avLst/>
           </a:prstGeom>
+          <a:noFill/>
+          <a:ln>
+            <a:noFill/>
+          </a:ln>
         </p:spPr>
         <p:txBody>
           <a:bodyPr anchorCtr="0" anchor="t" bIns="91425" lIns="91425" spcFirstLastPara="1" rIns="91425" wrap="square" tIns="91425">
@@ -772,12 +776,16 @@
           <a:lstStyle/>
           <a:p>
             <a:pPr indent="0" lvl="0" marL="0" rtl="0" algn="l">
-              <a:spcBef>
-                <a:spcPts val="0"/>
-              </a:spcBef>
-              <a:spcAft>
-                <a:spcPts val="0"/>
-              </a:spcAft>
+              <a:lnSpc>
+                <a:spcPct val="100000"/>
+              </a:lnSpc>
+              <a:spcBef>
+                <a:spcPts val="0"/>
+              </a:spcBef>
+              <a:spcAft>
+                <a:spcPts val="0"/>
+              </a:spcAft>
+              <a:buSzPts val="1100"/>
               <a:buNone/>
             </a:pPr>
             <a:r>
@@ -789,7 +797,7 @@
       </p:sp>
       <p:sp>
         <p:nvSpPr>
-          <p:cNvPr id="257" name="Google Shape;257;g3f6ecb44592_2_205:notes"/>
+          <p:cNvPr id="257" name="Google Shape;257;g3f88a2c7065_4_205:notes"/>
           <p:cNvSpPr/>
           <p:nvPr>
             <p:ph idx="2" type="sldImg"/>
@@ -820,6 +828,16 @@
               </a:path>
             </a:pathLst>
           </a:custGeom>
+          <a:noFill/>
+          <a:ln cap="flat" cmpd="sng" w="9525">
+            <a:solidFill>
+              <a:srgbClr val="000000"/>
+            </a:solidFill>
+            <a:prstDash val="solid"/>
+            <a:round/>
+            <a:headEnd len="sm" w="sm" type="none"/>
+            <a:tailEnd len="sm" w="sm" type="none"/>
+          </a:ln>
         </p:spPr>
       </p:sp>
     </p:spTree>
@@ -25378,7 +25396,7 @@
                 <a:cs typeface="Montserrat SemiBold"/>
                 <a:sym typeface="Montserrat SemiBold"/>
               </a:rPr>
-              <a:t>3</a:t>
+              <a:t>25</a:t>
             </a:r>
             <a:r>
               <a:rPr b="1" i="0" lang="en" sz="3000" u="none" cap="none" strike="noStrike">
@@ -25390,7 +25408,7 @@
                 <a:cs typeface="Montserrat SemiBold"/>
                 <a:sym typeface="Montserrat SemiBold"/>
               </a:rPr>
-              <a:t>00,000 images on device.</a:t>
+              <a:t>,000 images on device.</a:t>
             </a:r>
             <a:endParaRPr b="0" i="0" sz="1400" u="none" cap="none" strike="noStrike">
               <a:solidFill>

</xml_diff>